<commit_message>
build: rebuild release APKs and regenerate presentation decks
</commit_message>
<xml_diff>
--- a/releases/JAROOS_Minimalist_Presentation.pptx
+++ b/releases/JAROOS_Minimalist_Presentation.pptx
@@ -3268,7 +3268,7 @@
               </a:defRPr>
             </a:pPr>
             <a:r>
-              <a:t>A minimalist, ad-free mobile learning environment pairing gamified tactile modules, 9 humanized companion voices, authentic Malayalam bedtime stories, and PIN-secured parental screen-time governance.</a:t>
+              <a:t>A minimalist, ad-free mobile learning environment pairing gamified tactile modules, 100% on-device Piper neural voices, 3D Virtual Companion Simulator, authentic Malayalam bedtime stories, and PIN-secured parental screen-time governance.</a:t>
             </a:r>
           </a:p>
           <a:p>
@@ -3280,7 +3280,7 @@
               </a:defRPr>
             </a:pPr>
             <a:r>
-              <a:t>Flutter &amp; Dart  •  100% Offline-Ready  •  Zero Ads  •  Auto-Detect TTS  •  Parent Gate</a:t>
+              <a:t>Flutter &amp; Dart  •  100% Offline Piper Neural TTS  •  Zero Ads  •  3D Virtual Simulator  •  Parent Gate</a:t>
             </a:r>
           </a:p>
         </p:txBody>
@@ -4697,7 +4697,7 @@
                   <a:srgbClr val="0F172A"/>
                 </a:solidFill>
               </a:rPr>
-              <a:t>Media &amp; Culture Hub: </a:t>
+              <a:t>Interactive 3D Simulator: </a:t>
             </a:r>
             <a:r>
               <a:rPr sz="1000">
@@ -4705,7 +4705,7 @@
                   <a:srgbClr val="475569"/>
                 </a:solidFill>
               </a:rPr>
-              <a:t>Wildlife Safari, Fruits &amp; Veggies, Musical Fun Rhymes player.</a:t>
+              <a:t>Voice repetition, multi-zone touch physics (hair, cheek, belly), snack feeding.</a:t>
             </a:r>
           </a:p>
           <a:p>
@@ -4736,7 +4736,7 @@
                   <a:srgbClr val="475569"/>
                 </a:solidFill>
               </a:rPr>
-              <a:t>12 moral stories with 1-tap language filtering and 'Read to Me 🔊'.</a:t>
+              <a:t>12 moral stories with 1-tap bilingual filtering and neural narration.</a:t>
             </a:r>
           </a:p>
           <a:p>
@@ -4847,7 +4847,7 @@
               </a:defRPr>
             </a:pPr>
             <a:r>
-              <a:t>Algorithm 1: Script-Aware TTS</a:t>
+              <a:t>Algorithm 1: On-Device Neural TTS</a:t>
             </a:r>
           </a:p>
         </p:txBody>
@@ -4893,7 +4893,7 @@
                   <a:srgbClr val="0F172A"/>
                 </a:solidFill>
               </a:rPr>
-              <a:t>Step 1 (Input): </a:t>
+              <a:t>Step 1 (Input &amp; Script Check): </a:t>
             </a:r>
             <a:r>
               <a:rPr sz="1000">
@@ -4901,7 +4901,7 @@
                   <a:srgbClr val="475569"/>
                 </a:solidFill>
               </a:rPr>
-              <a:t>Ingest text payload into ModularTtsService.speak(text).</a:t>
+              <a:t>Ingest text into PiperTtsService; inspect for Malayalam unicode range [\u0D00-\u0D7F].</a:t>
             </a:r>
           </a:p>
           <a:p>
@@ -4924,7 +4924,7 @@
                   <a:srgbClr val="0F172A"/>
                 </a:solidFill>
               </a:rPr>
-              <a:t>Step 2 (Regex Match): </a:t>
+              <a:t>Step 2 (Model Dispatch): </a:t>
             </a:r>
             <a:r>
               <a:rPr sz="1000">
@@ -4932,7 +4932,7 @@
                   <a:srgbClr val="475569"/>
                 </a:solidFill>
               </a:rPr>
-              <a:t>Inspect text for Malayalam unicode range [\u0D00-\u0D7F].</a:t>
+              <a:t>Route to ml_IN-arjun-medium or en_US-lessac-medium INT8 ONNX model.</a:t>
             </a:r>
           </a:p>
           <a:p>
@@ -4955,7 +4955,7 @@
                   <a:srgbClr val="0F172A"/>
                 </a:solidFill>
               </a:rPr>
-              <a:t>Step 3 (Branch A): </a:t>
+              <a:t>Step 3 (Neural Synthesis): </a:t>
             </a:r>
             <a:r>
               <a:rPr sz="1000">
@@ -4963,7 +4963,7 @@
                   <a:srgbClr val="475569"/>
                 </a:solidFill>
               </a:rPr>
-              <a:t>If Malayalam, set language to 'ml-IN', pitch to 1.24, rate to 0.42.</a:t>
+              <a:t>Execute sherpa_onnx.OfflineTts to generate raw 16-bit PCM audio samples.</a:t>
             </a:r>
           </a:p>
           <a:p>
@@ -4986,7 +4986,7 @@
                   <a:srgbClr val="0F172A"/>
                 </a:solidFill>
               </a:rPr>
-              <a:t>Step 4 (Branch B): </a:t>
+              <a:t>Step 4 (Pitch Caricature): </a:t>
             </a:r>
             <a:r>
               <a:rPr sz="1000">
@@ -4994,7 +4994,7 @@
                   <a:srgbClr val="475569"/>
                 </a:solidFill>
               </a:rPr>
-              <a:t>If English, apply selected companion (e.g. Sparky pitch=1.34).</a:t>
+              <a:t>If in Simulator mode, modulate sample rate by 1.65x for Talking Tom mimicry.</a:t>
             </a:r>
           </a:p>
           <a:p>
@@ -5017,7 +5017,7 @@
                   <a:srgbClr val="0F172A"/>
                 </a:solidFill>
               </a:rPr>
-              <a:t>Step 5 (Restore): </a:t>
+              <a:t>Step 5 (Audio Playback): </a:t>
             </a:r>
             <a:r>
               <a:rPr sz="1000">
@@ -5025,7 +5025,7 @@
                   <a:srgbClr val="475569"/>
                 </a:solidFill>
               </a:rPr>
-              <a:t>Restore active companion profile immediately after utterance.</a:t>
+              <a:t>Write RIFF/WAV header and stream directly through audioplayers.</a:t>
             </a:r>
           </a:p>
         </p:txBody>
@@ -5579,7 +5579,7 @@
                   <a:srgbClr val="475569"/>
                 </a:solidFill>
               </a:rPr>
-              <a:t>55/55 tests passed cleanly (100% pass rate) across all modules.</a:t>
+              <a:t>73/73 tests passed cleanly (100% pass rate) across all modules.</a:t>
             </a:r>
           </a:p>
           <a:p>
@@ -5641,7 +5641,7 @@
                   <a:srgbClr val="475569"/>
                 </a:solidFill>
               </a:rPr>
-              <a:t>Sub-50ms trigger response on tactile card clicks and speech synthesis.</a:t>
+              <a:t>Sub-50ms trigger response on tactile card clicks and neural speech synthesis.</a:t>
             </a:r>
           </a:p>
           <a:p>
@@ -5672,7 +5672,7 @@
                   <a:srgbClr val="475569"/>
                 </a:solidFill>
               </a:rPr>
-              <a:t>54.89 MB standalone APK with zero external asset streaming dependencies.</a:t>
+              <a:t>Standalone offline APK with zero external server or streaming dependencies.</a:t>
             </a:r>
           </a:p>
           <a:p>
@@ -5703,7 +5703,7 @@
                   <a:srgbClr val="475569"/>
                 </a:solidFill>
               </a:rPr>
-              <a:t>100% of modules, audio voices, and stories operational in airplane mode.</a:t>
+              <a:t>100% of modules, neural voices, and stories operational in airplane mode.</a:t>
             </a:r>
           </a:p>
         </p:txBody>
@@ -5790,7 +5790,7 @@
       </p:sp>
       <p:pic>
         <p:nvPicPr>
-          <p:cNvPr id="10" name="Picture 9" descr="design_reference.jpg"/>
+          <p:cNvPr id="10" name="Picture 9" descr="jaroos_jungle_splash_1789467376903.jpg"/>
           <p:cNvPicPr>
             <a:picLocks noChangeAspect="1"/>
           </p:cNvPicPr>
@@ -5805,7 +5805,7 @@
         <p:spPr>
           <a:xfrm>
             <a:off x="6492240" y="2331720"/>
-            <a:ext cx="2331720" cy="3500999"/>
+            <a:ext cx="2286000" cy="4095750"/>
           </a:xfrm>
           <a:prstGeom prst="rect">
             <a:avLst/>
@@ -5814,7 +5814,7 @@
       </p:pic>
       <p:pic>
         <p:nvPicPr>
-          <p:cNvPr id="11" name="Picture 10" descr="splash_game_bg.jpg"/>
+          <p:cNvPr id="11" name="Picture 10" descr="simulator_character_preview.png"/>
           <p:cNvPicPr>
             <a:picLocks noChangeAspect="1"/>
           </p:cNvPicPr>
@@ -5829,7 +5829,7 @@
         <p:spPr>
           <a:xfrm>
             <a:off x="8961120" y="2331720"/>
-            <a:ext cx="2331720" cy="4177665"/>
+            <a:ext cx="2286000" cy="3061607"/>
           </a:xfrm>
           <a:prstGeom prst="rect">
             <a:avLst/>
@@ -5866,7 +5866,7 @@
               </a:defRPr>
             </a:pPr>
             <a:r>
-              <a:t>Visual UI Showcase: Learning Path, Story Reader &amp; Splash Animation</a:t>
+              <a:t>Visual UI Showcase: 3D Jungle Animated Splash &amp; 3D Interactive Virtual Simulator</a:t>
             </a:r>
           </a:p>
         </p:txBody>
@@ -6185,7 +6185,7 @@
                   <a:srgbClr val="0F172A"/>
                 </a:solidFill>
               </a:rPr>
-              <a:t>Multi-Companion Voice AI: </a:t>
+              <a:t>100% On-Device Neural TTS: </a:t>
             </a:r>
             <a:r>
               <a:rPr sz="1000">
@@ -6193,7 +6193,7 @@
                   <a:srgbClr val="475569"/>
                 </a:solidFill>
               </a:rPr>
-              <a:t>Replaced robotic monotone with 9 pitch-tuned child companion personas.</a:t>
+              <a:t>Replaced robotic monotone with bundled int8 Piper models via C++ ONNX Runtime.</a:t>
             </a:r>
           </a:p>
           <a:p>
@@ -6216,7 +6216,7 @@
                   <a:srgbClr val="0F172A"/>
                 </a:solidFill>
               </a:rPr>
-              <a:t>Regional Heritage Preserved: </a:t>
+              <a:t>Interactive 3D Virtual Companion: </a:t>
             </a:r>
             <a:r>
               <a:rPr sz="1000">
@@ -6224,7 +6224,7 @@
                   <a:srgbClr val="475569"/>
                 </a:solidFill>
               </a:rPr>
-              <a:t>Integrated authentic Malayalam moral tales with clean English navigation.</a:t>
+              <a:t>Developed real-time 'Talking Tom' repetition and touch physics.</a:t>
             </a:r>
           </a:p>
           <a:p>
@@ -6412,7 +6412,7 @@
                   <a:srgbClr val="0F172A"/>
                 </a:solidFill>
               </a:rPr>
-              <a:t>Zero Ad Intrusions: </a:t>
+              <a:t>Zero Server &amp; Cloud Overhead: </a:t>
             </a:r>
             <a:r>
               <a:rPr sz="1000">
@@ -6420,7 +6420,7 @@
                   <a:srgbClr val="475569"/>
                 </a:solidFill>
               </a:rPr>
-              <a:t>100% ad-free, secure, and privacy-first environment for children.</a:t>
+              <a:t>Fully autonomous offline mobile architecture running on device CPU.</a:t>
             </a:r>
           </a:p>
           <a:p>
@@ -6443,7 +6443,7 @@
                   <a:srgbClr val="0F172A"/>
                 </a:solidFill>
               </a:rPr>
-              <a:t>Zero Internet Dependency: </a:t>
+              <a:t>Cultural Preservation: </a:t>
             </a:r>
             <a:r>
               <a:rPr sz="1000">
@@ -6451,7 +6451,7 @@
                   <a:srgbClr val="475569"/>
                 </a:solidFill>
               </a:rPr>
-              <a:t>Completely self-contained 54.89 MB APK running offline.</a:t>
+              <a:t>Integrated authentic Malayalam bedtime stories with native phonetics.</a:t>
             </a:r>
           </a:p>
           <a:p>
@@ -6482,7 +6482,7 @@
                   <a:srgbClr val="475569"/>
                 </a:solidFill>
               </a:rPr>
-              <a:t>All 55 automated unit/widget tests passing with zero layout overflows.</a:t>
+              <a:t>All 73 automated tests passing, production release v1.4.0 deployed to GitHub.</a:t>
             </a:r>
           </a:p>
         </p:txBody>
@@ -8480,7 +8480,7 @@
               </a:defRPr>
             </a:pPr>
             <a:r>
-              <a:t>Test validation (55/55 passed) and UI.</a:t>
+              <a:t>Test validation (73/73 passed) and UI.</a:t>
             </a:r>
           </a:p>
         </p:txBody>
@@ -11285,7 +11285,7 @@
                   <a:srgbClr val="0F172A"/>
                 </a:solidFill>
               </a:rPr>
-              <a:t>Multi-Companion Voice AI: </a:t>
+              <a:t>100% On-Device Neural TTS: </a:t>
             </a:r>
             <a:r>
               <a:rPr sz="1000">
@@ -11293,7 +11293,7 @@
                   <a:srgbClr val="475569"/>
                 </a:solidFill>
               </a:rPr>
-              <a:t>9 distinct selectable companions (Sparky, Dora, Unni, Meenu, etc.).</a:t>
+              <a:t>Bundled INT8 Piper neural models for English and Malayalam with zero server dependency.</a:t>
             </a:r>
           </a:p>
           <a:p>
@@ -11316,7 +11316,7 @@
                   <a:srgbClr val="0F172A"/>
                 </a:solidFill>
               </a:rPr>
-              <a:t>Dual-Language Bedtime Stories: </a:t>
+              <a:t>Interactive 3D Simulator: </a:t>
             </a:r>
             <a:r>
               <a:rPr sz="1000">
@@ -11324,7 +11324,7 @@
                   <a:srgbClr val="475569"/>
                 </a:solidFill>
               </a:rPr>
-              <a:t>6 classic English + 6 authentic Malayalam tales with 'Read to Me 🔊'.</a:t>
+              <a:t>Talking Tom kid companion with voice mimicry, touch physics, and snack feeding.</a:t>
             </a:r>
           </a:p>
           <a:p>
@@ -11355,7 +11355,7 @@
                   <a:srgbClr val="475569"/>
                 </a:solidFill>
               </a:rPr>
-              <a:t>PIN-secured dashboard with screen-time limits and module switches.</a:t>
+              <a:t>PIN-secured dashboard with screen-time limits (15–60 min) and module switches.</a:t>
             </a:r>
           </a:p>
         </p:txBody>
@@ -11489,7 +11489,7 @@
                   <a:srgbClr val="475569"/>
                 </a:solidFill>
               </a:rPr>
-              <a:t>Requires physical card taps and interactive choices to trigger rewards.</a:t>
+              <a:t>Replaces mind-numbing video streams with hands-on touch tasks and companion interaction.</a:t>
             </a:r>
           </a:p>
           <a:p>
@@ -11512,7 +11512,7 @@
                   <a:srgbClr val="0F172A"/>
                 </a:solidFill>
               </a:rPr>
-              <a:t>Humanized Emotion: </a:t>
+              <a:t>Emotional Neural Voice AI: </a:t>
             </a:r>
             <a:r>
               <a:rPr sz="1000">
@@ -11520,7 +11520,7 @@
                   <a:srgbClr val="475569"/>
                 </a:solidFill>
               </a:rPr>
-              <a:t>Pitch-modulated voices with cheerful encouragement replace robotic monotone.</a:t>
+              <a:t>Precompiled C++ ONNX Runtime delivers warm, natural humanized speech locally.</a:t>
             </a:r>
           </a:p>
           <a:p>
@@ -11708,7 +11708,7 @@
                   <a:srgbClr val="0F172A"/>
                 </a:solidFill>
               </a:rPr>
-              <a:t>100% Ad-Free &amp; Safe: </a:t>
+              <a:t>100% Ad-Free &amp; Offline: </a:t>
             </a:r>
             <a:r>
               <a:rPr sz="1000">
@@ -11716,7 +11716,7 @@
                   <a:srgbClr val="475569"/>
                 </a:solidFill>
               </a:rPr>
-              <a:t>Zero advertisements, zero analytics tracking, and zero hidden payments.</a:t>
+              <a:t>Zero ads, zero tracking, and runs fully on physical hardware with zero internet.</a:t>
             </a:r>
           </a:p>
           <a:p>
@@ -11739,7 +11739,7 @@
                   <a:srgbClr val="0F172A"/>
                 </a:solidFill>
               </a:rPr>
-              <a:t>Full Offline Functionality: </a:t>
+              <a:t>Real-Time Voice Caricature: </a:t>
             </a:r>
             <a:r>
               <a:rPr sz="1000">
@@ -11747,7 +11747,7 @@
                   <a:srgbClr val="475569"/>
                 </a:solidFill>
               </a:rPr>
-              <a:t>Entire 54.89 MB app executes locally with zero network latency.</a:t>
+              <a:t>Instant 1.65x pitch modulation for child laughter and phonetic mimicry.</a:t>
             </a:r>
           </a:p>
           <a:p>
@@ -11770,7 +11770,7 @@
                   <a:srgbClr val="0F172A"/>
                 </a:solidFill>
               </a:rPr>
-              <a:t>Adaptive TTS Switching: </a:t>
+              <a:t>Zero Cloud Costs: </a:t>
             </a:r>
             <a:r>
               <a:rPr sz="1000">
@@ -11778,7 +11778,7 @@
                   <a:srgbClr val="475569"/>
                 </a:solidFill>
               </a:rPr>
-              <a:t>Automatically switches to native ml-IN voice when reading Malayalam.</a:t>
+              <a:t>Eliminates recurring cloud API billing by running neural inference on device CPU.</a:t>
             </a:r>
           </a:p>
           <a:p>
@@ -11809,7 +11809,7 @@
                   <a:srgbClr val="475569"/>
                 </a:solidFill>
               </a:rPr>
-              <a:t>Fluid 60–120 FPS animations on phones and tablets.</a:t>
+              <a:t>Fluid 60–120 FPS animations on phones and tablets with sub-50ms audio latency.</a:t>
             </a:r>
           </a:p>
         </p:txBody>
@@ -12505,7 +12505,7 @@
               </a:defRPr>
             </a:pPr>
             <a:r>
-              <a:t>Audio &amp; Voice AI</a:t>
+              <a:t>Neural Audio &amp; Voice AI</a:t>
             </a:r>
           </a:p>
         </p:txBody>
@@ -12551,7 +12551,7 @@
                   <a:srgbClr val="0F172A"/>
                 </a:solidFill>
               </a:rPr>
-              <a:t>flutter_tts: </a:t>
+              <a:t>sherpa_onnx: </a:t>
             </a:r>
             <a:r>
               <a:rPr sz="1000">
@@ -12559,7 +12559,7 @@
                   <a:srgbClr val="475569"/>
                 </a:solidFill>
               </a:rPr>
-              <a:t>Native Android TextToSpeech engine integration.</a:t>
+              <a:t>High-performance C++ ONNX Runtime compiled for Android (arm64, armv7, x86_64).</a:t>
             </a:r>
           </a:p>
           <a:p>
@@ -12582,7 +12582,7 @@
                   <a:srgbClr val="0F172A"/>
                 </a:solidFill>
               </a:rPr>
-              <a:t>Dynamic Pitch/Rate: </a:t>
+              <a:t>Piper INT8 Models: </a:t>
             </a:r>
             <a:r>
               <a:rPr sz="1000">
@@ -12590,7 +12590,7 @@
                   <a:srgbClr val="475569"/>
                 </a:solidFill>
               </a:rPr>
-              <a:t>Pitches 0.92–1.34; speech rates 0.42–0.49.</a:t>
+              <a:t>Bundled quantized neural models for English (Lessac, Amy) and Malayalam (Arjun, Meera).</a:t>
             </a:r>
           </a:p>
           <a:p>
@@ -12613,7 +12613,7 @@
                   <a:srgbClr val="0F172A"/>
                 </a:solidFill>
               </a:rPr>
-              <a:t>audioplayers: </a:t>
+              <a:t>audioplayers &amp; DSP: </a:t>
             </a:r>
             <a:r>
               <a:rPr sz="1000">
@@ -12621,7 +12621,7 @@
                   <a:srgbClr val="475569"/>
                 </a:solidFill>
               </a:rPr>
-              <a:t>Asynchronous tactile chimes and celebration fanfares.</a:t>
+              <a:t>Real-time 16-bit PCM WAV playback with 1.65x pitch caricature shifting.</a:t>
             </a:r>
           </a:p>
           <a:p>
@@ -12644,7 +12644,7 @@
                   <a:srgbClr val="0F172A"/>
                 </a:solidFill>
               </a:rPr>
-              <a:t>Bilingual Routing: </a:t>
+              <a:t>espeak-ng Phonetics: </a:t>
             </a:r>
             <a:r>
               <a:rPr sz="1000">
@@ -12652,7 +12652,7 @@
                   <a:srgbClr val="475569"/>
                 </a:solidFill>
               </a:rPr>
-              <a:t>Instant switching between en-US and ml-IN.</a:t>
+              <a:t>Shared phoneme tables extracted to local storage on first launch.</a:t>
             </a:r>
           </a:p>
         </p:txBody>
@@ -12786,7 +12786,7 @@
                   <a:srgbClr val="475569"/>
                 </a:solidFill>
               </a:rPr>
-              <a:t>Local key-value and structured cache engine.</a:t>
+              <a:t>Local key-value and structured cache engine for stats.</a:t>
             </a:r>
           </a:p>
           <a:p>
@@ -12817,7 +12817,7 @@
                   <a:srgbClr val="475569"/>
                 </a:solidFill>
               </a:rPr>
-              <a:t>Fast atomic local reads/writes without internet.</a:t>
+              <a:t>Fast atomic local reads/writes without network latency.</a:t>
             </a:r>
           </a:p>
           <a:p>
@@ -13192,7 +13192,7 @@
                   <a:srgbClr val="475569"/>
                 </a:solidFill>
               </a:rPr>
-              <a:t>Navigation Shell, Early Learning Modules, Bedtime Stories Reader, Parent Dashboard.</a:t>
+              <a:t>Navigation Shell, Early Learning Modules, 3D Virtual Simulator, Bedtime Stories Reader, Parent Dashboard.</a:t>
             </a:r>
           </a:p>
           <a:p>
@@ -13240,7 +13240,7 @@
                   <a:srgbClr val="475569"/>
                 </a:solidFill>
               </a:rPr>
-              <a:t>ModularTtsService (voice personas &amp; script detection), SoundFxService (chimes), StorageService.</a:t>
+              <a:t>PiperTtsService (ONNX inference &amp; pitch DSP), SoundFxService (chimes), StorageService.</a:t>
             </a:r>
           </a:p>
           <a:p>
@@ -13264,7 +13264,7 @@
                   <a:srgbClr val="475569"/>
                 </a:solidFill>
               </a:rPr>
-              <a:t>Android OS, Native TTS Engine (Google Speech Services), Flash Storage (SharedPrefs XML).</a:t>
+              <a:t>Android OS, Native C++ ONNX Runtime (libonnxruntime.so), Flash Storage (SharedPrefs XML).</a:t>
             </a:r>
           </a:p>
         </p:txBody>

</xml_diff>